<commit_message>
Pitch : couverture en grille, sources de financement
Co-Authored-By: Claude Opus 5.5 <noreply@anthropic.com>
Claude-Session: https://claude.ai/code/session_01GhVoXRgaJJbfXgbund27Nd
</commit_message>
<xml_diff>
--- a/pitch/straw-pitch.pptx
+++ b/pitch/straw-pitch.pptx
@@ -120,44 +120,44 @@
   <p:extLst>
     <p:ext uri="{521415D9-36F7-43E2-AB2F-B90AF26B5E84}">
       <p14:sectionLst xmlns:p14="http://schemas.microsoft.com/office/powerpoint/2010/main">
-        <p14:section name="Ouverture" id="{e9591749-411a-ecd7-f6ef-973f5e752e55}">
+        <p14:section name="Ouverture" id="{7204aea3-ca7a-ed80-3384-739de0b47224}">
           <p14:sldIdLst>
             <p14:sldId id="256"/>
           </p14:sldIdLst>
         </p14:section>
-        <p14:section name="Problème &amp; solution" id="{3487cc49-c0e8-5b4a-60e5-817f3ac2170a}">
+        <p14:section name="Problème &amp; solution" id="{4632e516-8fbd-2a72-1e52-070e455ff1c2}">
           <p14:sldIdLst>
             <p14:sldId id="257"/>
             <p14:sldId id="258"/>
             <p14:sldId id="259"/>
           </p14:sldIdLst>
         </p14:section>
-        <p14:section name="Marché" id="{b3fa34e3-c3ab-74fd-9801-716445f582ef}">
+        <p14:section name="Marché" id="{6d482c56-6024-d019-550d-5fec3f7702f2}">
           <p14:sldIdLst>
             <p14:sldId id="260"/>
             <p14:sldId id="261"/>
             <p14:sldId id="262"/>
           </p14:sldIdLst>
         </p14:section>
-        <p14:section name="Modèle &amp; croissance" id="{15052b1f-fe01-a596-4513-333aedf5981d}">
+        <p14:section name="Modèle &amp; croissance" id="{120cc276-6f5b-7d4a-8d7e-26268a82916c}">
           <p14:sldIdLst>
             <p14:sldId id="263"/>
             <p14:sldId id="264"/>
             <p14:sldId id="265"/>
           </p14:sldIdLst>
         </p14:section>
-        <p14:section name="Équipe &amp; financement" id="{a00968c7-068d-88db-04a8-5f1a0c79ba81}">
+        <p14:section name="Équipe &amp; financement" id="{5187e759-a25d-f3de-b1b1-d79d06b7458d}">
           <p14:sldIdLst>
             <p14:sldId id="266"/>
             <p14:sldId id="267"/>
           </p14:sldIdLst>
         </p14:section>
-        <p14:section name="Conclusion" id="{79b56fd4-61c3-92c0-8f7c-ec348f2e8599}">
+        <p14:section name="Conclusion" id="{78b14caa-e71b-c7f3-d99e-009415409f01}">
           <p14:sldIdLst>
             <p14:sldId id="268"/>
           </p14:sldIdLst>
         </p14:section>
-        <p14:section name="Annexe" id="{2d5778cb-d1d9-cc13-2c9e-34692a6d849e}">
+        <p14:section name="Annexe" id="{089db976-a57a-2299-cd49-23679e441745}">
           <p14:sldIdLst>
             <p14:sldId id="269"/>
           </p14:sldIdLst>
@@ -1119,7 +1119,7 @@
           <a:p>
             <a:r>
               <a:rPr lang="en-US" dirty="0"/>
-              <a:t>[6:15 – 6:45] Pour lancer straw. active, j'estime un besoin d'amorçage d'environ 150 000 euros : d'abord la R&amp;D et les tests produit, puis un premier stock, le marketing de lancement et le réglementaire. Je suis transparente : ces montants sont indicatifs, car je n'ai pas encore le coût de production. La rentabilité viendra de l'abonnement, et je la chiffrerai dès que j'aurai les devis.</a:t>
+              <a:t>[6:15 – 6:45] Pour lancer straw. active, j'estime un besoin d'amorçage d'environ 150 000 euros : d'abord la R&amp;D et les tests produit, puis un premier stock, le marketing de lancement et le réglementaire. Pour démarrer, je m'appuie sur mon apport personnel et sur la love money, ma famille et mes proches. Ensuite, je solliciterai des prêts d'honneur et des aides publiques, comme Initiative France, Réseau Entreprendre ou Bpifrance. Je suis transparente : ces montants sont indicatifs, car je n'ai pas encore le coût de production. La rentabilité viendra de l'abonnement, et je la chiffrerai dès que j'aurai les devis.</a:t>
             </a:r>
             <a:endParaRPr lang="en-US" dirty="0"/>
           </a:p>
@@ -2872,13 +2872,14 @@
         </p:nvPicPr>
         <p:blipFill>
           <a:blip r:embed="rId1"/>
-          <a:srcRect l="0" r="0" t="0" b="0"/>
-          <a:stretch/>
+          <a:stretch>
+            <a:fillRect/>
+          </a:stretch>
         </p:blipFill>
         <p:spPr>
           <a:xfrm>
             <a:off x="4572000" y="457200"/>
-            <a:ext cx="960120" cy="3611880"/>
+            <a:ext cx="2011680" cy="2057400"/>
           </a:xfrm>
           <a:prstGeom prst="rect">
             <a:avLst/>
@@ -2887,13 +2888,35 @@
       </p:pic>
       <p:sp>
         <p:nvSpPr>
-          <p:cNvPr id="11" name="Shape 8"/>
+          <p:cNvPr id="11" name="tag-mini"/>
           <p:cNvSpPr/>
           <p:nvPr/>
         </p:nvSpPr>
         <p:spPr>
           <a:xfrm>
-            <a:off x="4572000" y="4206240"/>
+            <a:off x="4681728" y="2103120"/>
+            <a:ext cx="832104" cy="292608"/>
+          </a:xfrm>
+          <a:prstGeom prst="roundRect">
+            <a:avLst>
+              <a:gd name="adj" fmla="val 50000"/>
+            </a:avLst>
+          </a:prstGeom>
+          <a:solidFill>
+            <a:schemeClr val="bg2"/>
+          </a:solidFill>
+          <a:ln/>
+        </p:spPr>
+      </p:sp>
+      <p:sp>
+        <p:nvSpPr>
+          <p:cNvPr id="12" name="Shape 9"/>
+          <p:cNvSpPr/>
+          <p:nvPr/>
+        </p:nvSpPr>
+        <p:spPr>
+          <a:xfrm>
+            <a:off x="4773168" y="2185416"/>
             <a:ext cx="128016" cy="128016"/>
           </a:xfrm>
           <a:prstGeom prst="ellipse">
@@ -2907,14 +2930,14 @@
       </p:sp>
       <p:sp>
         <p:nvSpPr>
-          <p:cNvPr id="12" name="Text 9"/>
+          <p:cNvPr id="13" name="Text 10"/>
           <p:cNvSpPr txBox="1"/>
           <p:nvPr/>
         </p:nvSpPr>
         <p:spPr>
           <a:xfrm>
-            <a:off x="4754880" y="4142232"/>
-            <a:ext cx="777240" cy="256032"/>
+            <a:off x="4956048" y="2103120"/>
+            <a:ext cx="557784" cy="292608"/>
           </a:xfrm>
           <a:prstGeom prst="rect">
             <a:avLst/>
@@ -2930,9 +2953,9 @@
               <a:buNone/>
             </a:pPr>
             <a:r>
-              <a:rPr lang="en-US" sz="1200" dirty="0">
-                <a:solidFill>
-                  <a:schemeClr val="bg2"/>
+              <a:rPr lang="en-US" sz="1200" b="1" dirty="0">
+                <a:solidFill>
+                  <a:schemeClr val="tx1"/>
                 </a:solidFill>
               </a:rPr>
               <a:t>mini</a:t>
@@ -2943,7 +2966,7 @@
       </p:sp>
       <p:pic>
         <p:nvPicPr>
-          <p:cNvPr id="13" name="cover-active" descr="cover-active">    </p:cNvPr>
+          <p:cNvPr id="14" name="cover-active" descr="cover-active">    </p:cNvPr>
           <p:cNvPicPr>
             <a:picLocks noChangeAspect="1"/>
           </p:cNvPicPr>
@@ -2951,13 +2974,14 @@
         </p:nvPicPr>
         <p:blipFill>
           <a:blip r:embed="rId2"/>
-          <a:srcRect l="0" r="0" t="0" b="0"/>
-          <a:stretch/>
+          <a:stretch>
+            <a:fillRect/>
+          </a:stretch>
         </p:blipFill>
         <p:spPr>
           <a:xfrm>
-            <a:off x="5623560" y="457200"/>
-            <a:ext cx="960120" cy="3611880"/>
+            <a:off x="6675120" y="457200"/>
+            <a:ext cx="2011680" cy="2057400"/>
           </a:xfrm>
           <a:prstGeom prst="rect">
             <a:avLst/>
@@ -2966,13 +2990,35 @@
       </p:pic>
       <p:sp>
         <p:nvSpPr>
-          <p:cNvPr id="14" name="Shape 10"/>
+          <p:cNvPr id="15" name="tag-active"/>
           <p:cNvSpPr/>
           <p:nvPr/>
         </p:nvSpPr>
         <p:spPr>
           <a:xfrm>
-            <a:off x="5623560" y="4206240"/>
+            <a:off x="6784848" y="2103120"/>
+            <a:ext cx="996696" cy="292608"/>
+          </a:xfrm>
+          <a:prstGeom prst="roundRect">
+            <a:avLst>
+              <a:gd name="adj" fmla="val 50000"/>
+            </a:avLst>
+          </a:prstGeom>
+          <a:solidFill>
+            <a:schemeClr val="bg2"/>
+          </a:solidFill>
+          <a:ln/>
+        </p:spPr>
+      </p:sp>
+      <p:sp>
+        <p:nvSpPr>
+          <p:cNvPr id="16" name="Shape 12"/>
+          <p:cNvSpPr/>
+          <p:nvPr/>
+        </p:nvSpPr>
+        <p:spPr>
+          <a:xfrm>
+            <a:off x="6876288" y="2185416"/>
             <a:ext cx="128016" cy="128016"/>
           </a:xfrm>
           <a:prstGeom prst="ellipse">
@@ -2986,14 +3032,14 @@
       </p:sp>
       <p:sp>
         <p:nvSpPr>
-          <p:cNvPr id="15" name="Text 11"/>
+          <p:cNvPr id="17" name="Text 13"/>
           <p:cNvSpPr txBox="1"/>
           <p:nvPr/>
         </p:nvSpPr>
         <p:spPr>
           <a:xfrm>
-            <a:off x="5806440" y="4142232"/>
-            <a:ext cx="777240" cy="256032"/>
+            <a:off x="7059168" y="2103120"/>
+            <a:ext cx="722376" cy="292608"/>
           </a:xfrm>
           <a:prstGeom prst="rect">
             <a:avLst/>
@@ -3009,9 +3055,9 @@
               <a:buNone/>
             </a:pPr>
             <a:r>
-              <a:rPr lang="en-US" sz="1200" dirty="0">
-                <a:solidFill>
-                  <a:schemeClr val="bg2"/>
+              <a:rPr lang="en-US" sz="1200" b="1" dirty="0">
+                <a:solidFill>
+                  <a:schemeClr val="tx1"/>
                 </a:solidFill>
               </a:rPr>
               <a:t>active</a:t>
@@ -3022,7 +3068,7 @@
       </p:sp>
       <p:pic>
         <p:nvPicPr>
-          <p:cNvPr id="16" name="cover-luna" descr="cover-luna">    </p:cNvPr>
+          <p:cNvPr id="18" name="cover-luna" descr="cover-luna">    </p:cNvPr>
           <p:cNvPicPr>
             <a:picLocks noChangeAspect="1"/>
           </p:cNvPicPr>
@@ -3030,13 +3076,14 @@
         </p:nvPicPr>
         <p:blipFill>
           <a:blip r:embed="rId3"/>
-          <a:srcRect l="0" r="0" t="0" b="0"/>
-          <a:stretch/>
+          <a:stretch>
+            <a:fillRect/>
+          </a:stretch>
         </p:blipFill>
         <p:spPr>
           <a:xfrm>
-            <a:off x="6675120" y="457200"/>
-            <a:ext cx="960120" cy="3611880"/>
+            <a:off x="4572000" y="2606040"/>
+            <a:ext cx="2011680" cy="2057400"/>
           </a:xfrm>
           <a:prstGeom prst="rect">
             <a:avLst/>
@@ -3045,13 +3092,35 @@
       </p:pic>
       <p:sp>
         <p:nvSpPr>
-          <p:cNvPr id="17" name="Shape 12"/>
+          <p:cNvPr id="19" name="tag-luna"/>
           <p:cNvSpPr/>
           <p:nvPr/>
         </p:nvSpPr>
         <p:spPr>
           <a:xfrm>
-            <a:off x="6675120" y="4206240"/>
+            <a:off x="4681728" y="4251960"/>
+            <a:ext cx="832104" cy="292608"/>
+          </a:xfrm>
+          <a:prstGeom prst="roundRect">
+            <a:avLst>
+              <a:gd name="adj" fmla="val 50000"/>
+            </a:avLst>
+          </a:prstGeom>
+          <a:solidFill>
+            <a:schemeClr val="bg2"/>
+          </a:solidFill>
+          <a:ln/>
+        </p:spPr>
+      </p:sp>
+      <p:sp>
+        <p:nvSpPr>
+          <p:cNvPr id="20" name="Shape 15"/>
+          <p:cNvSpPr/>
+          <p:nvPr/>
+        </p:nvSpPr>
+        <p:spPr>
+          <a:xfrm>
+            <a:off x="4773168" y="4334256"/>
             <a:ext cx="128016" cy="128016"/>
           </a:xfrm>
           <a:prstGeom prst="ellipse">
@@ -3065,14 +3134,14 @@
       </p:sp>
       <p:sp>
         <p:nvSpPr>
-          <p:cNvPr id="18" name="Text 13"/>
+          <p:cNvPr id="21" name="Text 16"/>
           <p:cNvSpPr txBox="1"/>
           <p:nvPr/>
         </p:nvSpPr>
         <p:spPr>
           <a:xfrm>
-            <a:off x="6858000" y="4142232"/>
-            <a:ext cx="777240" cy="256032"/>
+            <a:off x="4956048" y="4251960"/>
+            <a:ext cx="557784" cy="292608"/>
           </a:xfrm>
           <a:prstGeom prst="rect">
             <a:avLst/>
@@ -3088,9 +3157,9 @@
               <a:buNone/>
             </a:pPr>
             <a:r>
-              <a:rPr lang="en-US" sz="1200" dirty="0">
-                <a:solidFill>
-                  <a:schemeClr val="bg2"/>
+              <a:rPr lang="en-US" sz="1200" b="1" dirty="0">
+                <a:solidFill>
+                  <a:schemeClr val="tx1"/>
                 </a:solidFill>
               </a:rPr>
               <a:t>luna</a:t>
@@ -3101,7 +3170,7 @@
       </p:sp>
       <p:pic>
         <p:nvPicPr>
-          <p:cNvPr id="19" name="cover-silver" descr="cover-silver">    </p:cNvPr>
+          <p:cNvPr id="22" name="cover-silver" descr="cover-silver">    </p:cNvPr>
           <p:cNvPicPr>
             <a:picLocks noChangeAspect="1"/>
           </p:cNvPicPr>
@@ -3109,13 +3178,14 @@
         </p:nvPicPr>
         <p:blipFill>
           <a:blip r:embed="rId4"/>
-          <a:srcRect l="0" r="0" t="0" b="0"/>
-          <a:stretch/>
+          <a:stretch>
+            <a:fillRect/>
+          </a:stretch>
         </p:blipFill>
         <p:spPr>
           <a:xfrm>
-            <a:off x="7726680" y="457200"/>
-            <a:ext cx="960120" cy="3611880"/>
+            <a:off x="6675120" y="2606040"/>
+            <a:ext cx="2011680" cy="2057400"/>
           </a:xfrm>
           <a:prstGeom prst="rect">
             <a:avLst/>
@@ -3124,13 +3194,35 @@
       </p:pic>
       <p:sp>
         <p:nvSpPr>
-          <p:cNvPr id="20" name="Shape 14"/>
+          <p:cNvPr id="23" name="tag-silver"/>
           <p:cNvSpPr/>
           <p:nvPr/>
         </p:nvSpPr>
         <p:spPr>
           <a:xfrm>
-            <a:off x="7726680" y="4206240"/>
+            <a:off x="6784848" y="4251960"/>
+            <a:ext cx="996696" cy="292608"/>
+          </a:xfrm>
+          <a:prstGeom prst="roundRect">
+            <a:avLst>
+              <a:gd name="adj" fmla="val 50000"/>
+            </a:avLst>
+          </a:prstGeom>
+          <a:solidFill>
+            <a:schemeClr val="bg2"/>
+          </a:solidFill>
+          <a:ln/>
+        </p:spPr>
+      </p:sp>
+      <p:sp>
+        <p:nvSpPr>
+          <p:cNvPr id="24" name="Shape 18"/>
+          <p:cNvSpPr/>
+          <p:nvPr/>
+        </p:nvSpPr>
+        <p:spPr>
+          <a:xfrm>
+            <a:off x="6876288" y="4334256"/>
             <a:ext cx="128016" cy="128016"/>
           </a:xfrm>
           <a:prstGeom prst="ellipse">
@@ -3144,14 +3236,14 @@
       </p:sp>
       <p:sp>
         <p:nvSpPr>
-          <p:cNvPr id="21" name="Text 15"/>
+          <p:cNvPr id="25" name="Text 19"/>
           <p:cNvSpPr txBox="1"/>
           <p:nvPr/>
         </p:nvSpPr>
         <p:spPr>
           <a:xfrm>
-            <a:off x="7909560" y="4142232"/>
-            <a:ext cx="777240" cy="256032"/>
+            <a:off x="7059168" y="4251960"/>
+            <a:ext cx="722376" cy="292608"/>
           </a:xfrm>
           <a:prstGeom prst="rect">
             <a:avLst/>
@@ -3167,9 +3259,9 @@
               <a:buNone/>
             </a:pPr>
             <a:r>
-              <a:rPr lang="en-US" sz="1200" dirty="0">
-                <a:solidFill>
-                  <a:schemeClr val="bg2"/>
+              <a:rPr lang="en-US" sz="1200" b="1" dirty="0">
+                <a:solidFill>
+                  <a:schemeClr val="tx1"/>
                 </a:solidFill>
               </a:rPr>
               <a:t>silver</a:t>
@@ -4956,7 +5048,7 @@
                   <a:schemeClr val="tx2"/>
                 </a:solidFill>
               </a:rPr>
-              <a:t>d'amorçage, pour passer du prototype au lancement de straw. active</a:t>
+              <a:t>d'amorçage pour : tests produit → lancement de straw. active → premiers abonnés</a:t>
             </a:r>
             <a:endParaRPr lang="en-US" sz="1300" dirty="0"/>
           </a:p>
@@ -5011,7 +5103,7 @@
                 <a:ea typeface="Cambria" pitchFamily="34" charset="-122"/>
                 <a:cs typeface="Cambria" pitchFamily="34" charset="-120"/>
               </a:rPr>
-              <a:t>ce que le financement permet</a:t>
+              <a:t>d'où vient le financement</a:t>
             </a:r>
             <a:endParaRPr lang="en-US" sz="1600" dirty="0"/>
           </a:p>
@@ -5019,18 +5111,18 @@
       </p:sp>
       <p:sp>
         <p:nvSpPr>
-          <p:cNvPr id="8" name="ms0"/>
+          <p:cNvPr id="8" name="fund0"/>
           <p:cNvSpPr/>
           <p:nvPr/>
         </p:nvSpPr>
         <p:spPr>
           <a:xfrm>
             <a:off x="4480560" y="1737360"/>
-            <a:ext cx="4206240" cy="530352"/>
+            <a:ext cx="4206240" cy="548640"/>
           </a:xfrm>
           <a:prstGeom prst="roundRect">
             <a:avLst>
-              <a:gd name="adj" fmla="val 13793"/>
+              <a:gd name="adj" fmla="val 13333"/>
             </a:avLst>
           </a:prstGeom>
           <a:solidFill>
@@ -5041,14 +5133,34 @@
       </p:sp>
       <p:sp>
         <p:nvSpPr>
-          <p:cNvPr id="9" name="Text 6"/>
+          <p:cNvPr id="9" name="Shape 6"/>
+          <p:cNvSpPr/>
+          <p:nvPr/>
+        </p:nvSpPr>
+        <p:spPr>
+          <a:xfrm>
+            <a:off x="4645152" y="1929384"/>
+            <a:ext cx="164592" cy="164592"/>
+          </a:xfrm>
+          <a:prstGeom prst="ellipse">
+            <a:avLst/>
+          </a:prstGeom>
+          <a:solidFill>
+            <a:schemeClr val="accent4"/>
+          </a:solidFill>
+          <a:ln/>
+        </p:spPr>
+      </p:sp>
+      <p:sp>
+        <p:nvSpPr>
+          <p:cNvPr id="10" name="Text 7"/>
           <p:cNvSpPr txBox="1"/>
           <p:nvPr/>
         </p:nvSpPr>
         <p:spPr>
           <a:xfrm>
-            <a:off x="4663440" y="1737360"/>
-            <a:ext cx="3931920" cy="530352"/>
+            <a:off x="4937760" y="1737360"/>
+            <a:ext cx="2834640" cy="548640"/>
           </a:xfrm>
           <a:prstGeom prst="rect">
             <a:avLst/>
@@ -5064,23 +5176,26 @@
               <a:buNone/>
             </a:pPr>
             <a:r>
-              <a:rPr lang="en-US" sz="1000" b="1" spc="200" kern="0" dirty="0">
+              <a:rPr lang="en-US" sz="1300" b="1" dirty="0">
+                <a:solidFill>
+                  <a:schemeClr val="tx1"/>
+                </a:solidFill>
+              </a:rPr>
+              <a:t>apport personnel</a:t>
+            </a:r>
+            <a:endParaRPr lang="en-US" sz="1300" dirty="0"/>
+          </a:p>
+          <a:p>
+            <a:pPr indent="0" marL="0">
+              <a:buNone/>
+            </a:pPr>
+            <a:r>
+              <a:rPr lang="en-US" sz="1100" dirty="0">
                 <a:solidFill>
                   <a:schemeClr val="tx2"/>
                 </a:solidFill>
               </a:rPr>
-              <a:t>JALON 1   </a:t>
-            </a:r>
-            <a:pPr indent="0" marL="0">
-              <a:buNone/>
-            </a:pPr>
-            <a:r>
-              <a:rPr lang="en-US" sz="1300" dirty="0">
-                <a:solidFill>
-                  <a:schemeClr val="tx1"/>
-                </a:solidFill>
-              </a:rPr>
-              <a:t>Tests produit et formules validées</a:t>
+              <a:t>La fondatrice investit dans son projet</a:t>
             </a:r>
             <a:endParaRPr lang="en-US" sz="1300" dirty="0"/>
           </a:p>
@@ -5088,18 +5203,54 @@
       </p:sp>
       <p:sp>
         <p:nvSpPr>
-          <p:cNvPr id="10" name="ms1"/>
+          <p:cNvPr id="11" name="Text 8"/>
+          <p:cNvSpPr txBox="1"/>
+          <p:nvPr/>
+        </p:nvSpPr>
+        <p:spPr>
+          <a:xfrm>
+            <a:off x="7726680" y="1737360"/>
+            <a:ext cx="868680" cy="548640"/>
+          </a:xfrm>
+          <a:prstGeom prst="rect">
+            <a:avLst/>
+          </a:prstGeom>
+          <a:noFill/>
+          <a:ln/>
+        </p:spPr>
+        <p:txBody>
+          <a:bodyPr wrap="square" lIns="0" tIns="0" rIns="0" bIns="0" rtlCol="0" anchor="ctr"/>
+          <a:lstStyle/>
+          <a:p>
+            <a:pPr algn="r" indent="0" marL="0">
+              <a:buNone/>
+            </a:pPr>
+            <a:r>
+              <a:rPr lang="en-US" sz="900" b="1" spc="100" kern="0" dirty="0">
+                <a:solidFill>
+                  <a:schemeClr val="tx2"/>
+                </a:solidFill>
+              </a:rPr>
+              <a:t>MAINTENANT</a:t>
+            </a:r>
+            <a:endParaRPr lang="en-US" sz="900" dirty="0"/>
+          </a:p>
+        </p:txBody>
+      </p:sp>
+      <p:sp>
+        <p:nvSpPr>
+          <p:cNvPr id="12" name="fund1"/>
           <p:cNvSpPr/>
           <p:nvPr/>
         </p:nvSpPr>
         <p:spPr>
           <a:xfrm>
             <a:off x="4480560" y="2377440"/>
-            <a:ext cx="4206240" cy="530352"/>
+            <a:ext cx="4206240" cy="548640"/>
           </a:xfrm>
           <a:prstGeom prst="roundRect">
             <a:avLst>
-              <a:gd name="adj" fmla="val 13793"/>
+              <a:gd name="adj" fmla="val 13333"/>
             </a:avLst>
           </a:prstGeom>
           <a:solidFill>
@@ -5110,14 +5261,34 @@
       </p:sp>
       <p:sp>
         <p:nvSpPr>
-          <p:cNvPr id="11" name="Text 8"/>
+          <p:cNvPr id="13" name="Shape 10"/>
+          <p:cNvSpPr/>
+          <p:nvPr/>
+        </p:nvSpPr>
+        <p:spPr>
+          <a:xfrm>
+            <a:off x="4645152" y="2569464"/>
+            <a:ext cx="164592" cy="164592"/>
+          </a:xfrm>
+          <a:prstGeom prst="ellipse">
+            <a:avLst/>
+          </a:prstGeom>
+          <a:solidFill>
+            <a:schemeClr val="accent1"/>
+          </a:solidFill>
+          <a:ln/>
+        </p:spPr>
+      </p:sp>
+      <p:sp>
+        <p:nvSpPr>
+          <p:cNvPr id="14" name="Text 11"/>
           <p:cNvSpPr txBox="1"/>
           <p:nvPr/>
         </p:nvSpPr>
         <p:spPr>
           <a:xfrm>
-            <a:off x="4663440" y="2377440"/>
-            <a:ext cx="3931920" cy="530352"/>
+            <a:off x="4937760" y="2377440"/>
+            <a:ext cx="2834640" cy="548640"/>
           </a:xfrm>
           <a:prstGeom prst="rect">
             <a:avLst/>
@@ -5133,23 +5304,26 @@
               <a:buNone/>
             </a:pPr>
             <a:r>
-              <a:rPr lang="en-US" sz="1000" b="1" spc="200" kern="0" dirty="0">
+              <a:rPr lang="en-US" sz="1300" b="1" dirty="0">
+                <a:solidFill>
+                  <a:schemeClr val="tx1"/>
+                </a:solidFill>
+              </a:rPr>
+              <a:t>love money</a:t>
+            </a:r>
+            <a:endParaRPr lang="en-US" sz="1300" dirty="0"/>
+          </a:p>
+          <a:p>
+            <a:pPr indent="0" marL="0">
+              <a:buNone/>
+            </a:pPr>
+            <a:r>
+              <a:rPr lang="en-US" sz="1100" dirty="0">
                 <a:solidFill>
                   <a:schemeClr val="tx2"/>
                 </a:solidFill>
               </a:rPr>
-              <a:t>JALON 2   </a:t>
-            </a:r>
-            <a:pPr indent="0" marL="0">
-              <a:buNone/>
-            </a:pPr>
-            <a:r>
-              <a:rPr lang="en-US" sz="1300" dirty="0">
-                <a:solidFill>
-                  <a:schemeClr val="tx1"/>
-                </a:solidFill>
-              </a:rPr>
-              <a:t>Lancement en ligne de straw. active</a:t>
+              <a:t>Famille et proches, premier cercle de confiance</a:t>
             </a:r>
             <a:endParaRPr lang="en-US" sz="1300" dirty="0"/>
           </a:p>
@@ -5157,18 +5331,54 @@
       </p:sp>
       <p:sp>
         <p:nvSpPr>
-          <p:cNvPr id="12" name="ms2"/>
+          <p:cNvPr id="15" name="Text 12"/>
+          <p:cNvSpPr txBox="1"/>
+          <p:nvPr/>
+        </p:nvSpPr>
+        <p:spPr>
+          <a:xfrm>
+            <a:off x="7726680" y="2377440"/>
+            <a:ext cx="868680" cy="548640"/>
+          </a:xfrm>
+          <a:prstGeom prst="rect">
+            <a:avLst/>
+          </a:prstGeom>
+          <a:noFill/>
+          <a:ln/>
+        </p:spPr>
+        <p:txBody>
+          <a:bodyPr wrap="square" lIns="0" tIns="0" rIns="0" bIns="0" rtlCol="0" anchor="ctr"/>
+          <a:lstStyle/>
+          <a:p>
+            <a:pPr algn="r" indent="0" marL="0">
+              <a:buNone/>
+            </a:pPr>
+            <a:r>
+              <a:rPr lang="en-US" sz="900" b="1" spc="100" kern="0" dirty="0">
+                <a:solidFill>
+                  <a:schemeClr val="tx2"/>
+                </a:solidFill>
+              </a:rPr>
+              <a:t>MAINTENANT</a:t>
+            </a:r>
+            <a:endParaRPr lang="en-US" sz="900" dirty="0"/>
+          </a:p>
+        </p:txBody>
+      </p:sp>
+      <p:sp>
+        <p:nvSpPr>
+          <p:cNvPr id="16" name="fund2"/>
           <p:cNvSpPr/>
           <p:nvPr/>
         </p:nvSpPr>
         <p:spPr>
           <a:xfrm>
             <a:off x="4480560" y="3017520"/>
-            <a:ext cx="4206240" cy="530352"/>
+            <a:ext cx="4206240" cy="548640"/>
           </a:xfrm>
           <a:prstGeom prst="roundRect">
             <a:avLst>
-              <a:gd name="adj" fmla="val 13793"/>
+              <a:gd name="adj" fmla="val 13333"/>
             </a:avLst>
           </a:prstGeom>
           <a:solidFill>
@@ -5179,14 +5389,34 @@
       </p:sp>
       <p:sp>
         <p:nvSpPr>
-          <p:cNvPr id="13" name="Text 10"/>
+          <p:cNvPr id="17" name="Shape 14"/>
+          <p:cNvSpPr/>
+          <p:nvPr/>
+        </p:nvSpPr>
+        <p:spPr>
+          <a:xfrm>
+            <a:off x="4645152" y="3209544"/>
+            <a:ext cx="164592" cy="164592"/>
+          </a:xfrm>
+          <a:prstGeom prst="ellipse">
+            <a:avLst/>
+          </a:prstGeom>
+          <a:solidFill>
+            <a:schemeClr val="accent2"/>
+          </a:solidFill>
+          <a:ln/>
+        </p:spPr>
+      </p:sp>
+      <p:sp>
+        <p:nvSpPr>
+          <p:cNvPr id="18" name="Text 15"/>
           <p:cNvSpPr txBox="1"/>
           <p:nvPr/>
         </p:nvSpPr>
         <p:spPr>
           <a:xfrm>
-            <a:off x="4663440" y="3017520"/>
-            <a:ext cx="3931920" cy="530352"/>
+            <a:off x="4937760" y="3017520"/>
+            <a:ext cx="2834640" cy="548640"/>
           </a:xfrm>
           <a:prstGeom prst="rect">
             <a:avLst/>
@@ -5202,23 +5432,26 @@
               <a:buNone/>
             </a:pPr>
             <a:r>
-              <a:rPr lang="en-US" sz="1000" b="1" spc="200" kern="0" dirty="0">
+              <a:rPr lang="en-US" sz="1300" b="1" dirty="0">
+                <a:solidFill>
+                  <a:schemeClr val="tx1"/>
+                </a:solidFill>
+              </a:rPr>
+              <a:t>prêts d'honneur &amp; aides</a:t>
+            </a:r>
+            <a:endParaRPr lang="en-US" sz="1300" dirty="0"/>
+          </a:p>
+          <a:p>
+            <a:pPr indent="0" marL="0">
+              <a:buNone/>
+            </a:pPr>
+            <a:r>
+              <a:rPr lang="en-US" sz="1100" dirty="0">
                 <a:solidFill>
                   <a:schemeClr val="tx2"/>
                 </a:solidFill>
               </a:rPr>
-              <a:t>JALON 3   </a:t>
-            </a:r>
-            <a:pPr indent="0" marL="0">
-              <a:buNone/>
-            </a:pPr>
-            <a:r>
-              <a:rPr lang="en-US" sz="1300" dirty="0">
-                <a:solidFill>
-                  <a:schemeClr val="tx1"/>
-                </a:solidFill>
-              </a:rPr>
-              <a:t>Premiers abonnés récurrents, puis straw. luna</a:t>
+              <a:t>Initiative France, Réseau Entreprendre, Bpifrance</a:t>
             </a:r>
             <a:endParaRPr lang="en-US" sz="1300" dirty="0"/>
           </a:p>
@@ -5226,7 +5459,43 @@
       </p:sp>
       <p:sp>
         <p:nvSpPr>
-          <p:cNvPr id="14" name="disclaimer"/>
+          <p:cNvPr id="19" name="Text 16"/>
+          <p:cNvSpPr txBox="1"/>
+          <p:nvPr/>
+        </p:nvSpPr>
+        <p:spPr>
+          <a:xfrm>
+            <a:off x="7726680" y="3017520"/>
+            <a:ext cx="868680" cy="548640"/>
+          </a:xfrm>
+          <a:prstGeom prst="rect">
+            <a:avLst/>
+          </a:prstGeom>
+          <a:noFill/>
+          <a:ln/>
+        </p:spPr>
+        <p:txBody>
+          <a:bodyPr wrap="square" lIns="0" tIns="0" rIns="0" bIns="0" rtlCol="0" anchor="ctr"/>
+          <a:lstStyle/>
+          <a:p>
+            <a:pPr algn="r" indent="0" marL="0">
+              <a:buNone/>
+            </a:pPr>
+            <a:r>
+              <a:rPr lang="en-US" sz="900" b="1" spc="100" kern="0" dirty="0">
+                <a:solidFill>
+                  <a:schemeClr val="tx2"/>
+                </a:solidFill>
+              </a:rPr>
+              <a:t>ENSUITE</a:t>
+            </a:r>
+            <a:endParaRPr lang="en-US" sz="900" dirty="0"/>
+          </a:p>
+        </p:txBody>
+      </p:sp>
+      <p:sp>
+        <p:nvSpPr>
+          <p:cNvPr id="20" name="disclaimer"/>
           <p:cNvSpPr/>
           <p:nvPr/>
         </p:nvSpPr>
@@ -5248,7 +5517,7 @@
       </p:sp>
       <p:sp>
         <p:nvSpPr>
-          <p:cNvPr id="15" name="Text 12"/>
+          <p:cNvPr id="21" name="Text 18"/>
           <p:cNvSpPr txBox="1"/>
           <p:nvPr/>
         </p:nvSpPr>
@@ -5362,8 +5631,9 @@
         </p:nvPicPr>
         <p:blipFill>
           <a:blip r:embed="rId1"/>
-          <a:srcRect l="0" r="0" t="0" b="0"/>
-          <a:stretch/>
+          <a:stretch>
+            <a:fillRect/>
+          </a:stretch>
         </p:blipFill>
         <p:spPr>
           <a:xfrm>
@@ -8328,8 +8598,9 @@
         </p:nvPicPr>
         <p:blipFill>
           <a:blip r:embed="rId1"/>
-          <a:srcRect l="0" r="0" t="0" b="0"/>
-          <a:stretch/>
+          <a:stretch>
+            <a:fillRect/>
+          </a:stretch>
         </p:blipFill>
         <p:spPr>
           <a:xfrm>

</xml_diff>

<commit_message>
Pitch : photos d'ambiance sur la diapo des 4 gammes
Co-Authored-By: Claude Opus 5.5 <noreply@anthropic.com>
Claude-Session: https://claude.ai/code/session_01GhVoXRgaJJbfXgbund27Nd
</commit_message>
<xml_diff>
--- a/pitch/straw-pitch.pptx
+++ b/pitch/straw-pitch.pptx
@@ -120,44 +120,44 @@
   <p:extLst>
     <p:ext uri="{521415D9-36F7-43E2-AB2F-B90AF26B5E84}">
       <p14:sectionLst xmlns:p14="http://schemas.microsoft.com/office/powerpoint/2010/main">
-        <p14:section name="Ouverture" id="{7204aea3-ca7a-ed80-3384-739de0b47224}">
+        <p14:section name="Ouverture" id="{1e802bd5-18c7-7a3e-64a0-25a9f81ade38}">
           <p14:sldIdLst>
             <p14:sldId id="256"/>
           </p14:sldIdLst>
         </p14:section>
-        <p14:section name="Problème &amp; solution" id="{4632e516-8fbd-2a72-1e52-070e455ff1c2}">
+        <p14:section name="Problème &amp; solution" id="{66091976-8e24-f144-f94c-e1dd42795b18}">
           <p14:sldIdLst>
             <p14:sldId id="257"/>
             <p14:sldId id="258"/>
             <p14:sldId id="259"/>
           </p14:sldIdLst>
         </p14:section>
-        <p14:section name="Marché" id="{6d482c56-6024-d019-550d-5fec3f7702f2}">
+        <p14:section name="Marché" id="{be1132f0-9f58-4bc5-e484-32bb1e1f271f}">
           <p14:sldIdLst>
             <p14:sldId id="260"/>
             <p14:sldId id="261"/>
             <p14:sldId id="262"/>
           </p14:sldIdLst>
         </p14:section>
-        <p14:section name="Modèle &amp; croissance" id="{120cc276-6f5b-7d4a-8d7e-26268a82916c}">
+        <p14:section name="Modèle &amp; croissance" id="{aec702be-1b8d-76da-214f-6a4f86732c88}">
           <p14:sldIdLst>
             <p14:sldId id="263"/>
             <p14:sldId id="264"/>
             <p14:sldId id="265"/>
           </p14:sldIdLst>
         </p14:section>
-        <p14:section name="Équipe &amp; financement" id="{5187e759-a25d-f3de-b1b1-d79d06b7458d}">
+        <p14:section name="Équipe &amp; financement" id="{d110f374-377d-ef7c-dafe-25290cf760bb}">
           <p14:sldIdLst>
             <p14:sldId id="266"/>
             <p14:sldId id="267"/>
           </p14:sldIdLst>
         </p14:section>
-        <p14:section name="Conclusion" id="{78b14caa-e71b-c7f3-d99e-009415409f01}">
+        <p14:section name="Conclusion" id="{1ea955f0-0fe2-03f5-d3c3-b588f4a9ff9a}">
           <p14:sldIdLst>
             <p14:sldId id="268"/>
           </p14:sldIdLst>
         </p14:section>
-        <p14:section name="Annexe" id="{089db976-a57a-2299-cd49-23679e441745}">
+        <p14:section name="Annexe" id="{83888670-75d6-8b52-a025-47076895ae98}">
           <p14:sldIdLst>
             <p14:sldId id="269"/>
           </p14:sldIdLst>
@@ -7766,7 +7766,7 @@
       </p:sp>
       <p:pic>
         <p:nvPicPr>
-          <p:cNvPr id="4" name="lineup-mini" descr="Étuis straw. mini">    </p:cNvPr>
+          <p:cNvPr id="4" name="mood-mini" descr="mood-mini">    </p:cNvPr>
           <p:cNvPicPr>
             <a:picLocks noChangeAspect="1"/>
           </p:cNvPicPr>
@@ -7780,159 +7780,17 @@
         </p:blipFill>
         <p:spPr>
           <a:xfrm>
-            <a:off x="457200" y="1280160"/>
-            <a:ext cx="1920240" cy="2011680"/>
+            <a:off x="457200" y="1234440"/>
+            <a:ext cx="1920240" cy="1828800"/>
           </a:xfrm>
           <a:prstGeom prst="rect">
             <a:avLst/>
           </a:prstGeom>
         </p:spPr>
       </p:pic>
-      <p:sp>
-        <p:nvSpPr>
-          <p:cNvPr id="5" name="Shape 2"/>
-          <p:cNvSpPr/>
-          <p:nvPr/>
-        </p:nvSpPr>
-        <p:spPr>
-          <a:xfrm>
-            <a:off x="457200" y="3474720"/>
-            <a:ext cx="146304" cy="146304"/>
-          </a:xfrm>
-          <a:prstGeom prst="ellipse">
-            <a:avLst/>
-          </a:prstGeom>
-          <a:solidFill>
-            <a:schemeClr val="accent3"/>
-          </a:solidFill>
-          <a:ln/>
-        </p:spPr>
-      </p:sp>
-      <p:sp>
-        <p:nvSpPr>
-          <p:cNvPr id="6" name="Text 3"/>
-          <p:cNvSpPr txBox="1"/>
-          <p:nvPr/>
-        </p:nvSpPr>
-        <p:spPr>
-          <a:xfrm>
-            <a:off x="676656" y="3383280"/>
-            <a:ext cx="1737360" cy="320040"/>
-          </a:xfrm>
-          <a:prstGeom prst="rect">
-            <a:avLst/>
-          </a:prstGeom>
-          <a:noFill/>
-          <a:ln/>
-        </p:spPr>
-        <p:txBody>
-          <a:bodyPr wrap="square" lIns="0" tIns="0" rIns="0" bIns="0" rtlCol="0" anchor="ctr"/>
-          <a:lstStyle/>
-          <a:p>
-            <a:pPr indent="0" marL="0">
-              <a:buNone/>
-            </a:pPr>
-            <a:r>
-              <a:rPr lang="en-US" sz="1700" b="1" dirty="0">
-                <a:solidFill>
-                  <a:schemeClr val="tx1"/>
-                </a:solidFill>
-              </a:rPr>
-              <a:t>straw. </a:t>
-            </a:r>
-            <a:pPr indent="0" marL="0">
-              <a:buNone/>
-            </a:pPr>
-            <a:r>
-              <a:rPr lang="en-US" sz="1700" i="1" dirty="0">
-                <a:solidFill>
-                  <a:schemeClr val="tx1"/>
-                </a:solidFill>
-                <a:latin typeface="Cambria" pitchFamily="34" charset="0"/>
-                <a:ea typeface="Cambria" pitchFamily="34" charset="-122"/>
-                <a:cs typeface="Cambria" pitchFamily="34" charset="-120"/>
-              </a:rPr>
-              <a:t>mini</a:t>
-            </a:r>
-            <a:endParaRPr lang="en-US" sz="1700" dirty="0"/>
-          </a:p>
-        </p:txBody>
-      </p:sp>
-      <p:sp>
-        <p:nvSpPr>
-          <p:cNvPr id="7" name="Text 4"/>
-          <p:cNvSpPr txBox="1"/>
-          <p:nvPr/>
-        </p:nvSpPr>
-        <p:spPr>
-          <a:xfrm>
-            <a:off x="457200" y="3730752"/>
-            <a:ext cx="1920240" cy="274320"/>
-          </a:xfrm>
-          <a:prstGeom prst="rect">
-            <a:avLst/>
-          </a:prstGeom>
-          <a:noFill/>
-          <a:ln/>
-        </p:spPr>
-        <p:txBody>
-          <a:bodyPr wrap="square" lIns="0" tIns="0" rIns="0" bIns="0" rtlCol="0" anchor="ctr"/>
-          <a:lstStyle/>
-          <a:p>
-            <a:pPr indent="0" marL="0">
-              <a:buNone/>
-            </a:pPr>
-            <a:r>
-              <a:rPr lang="en-US" sz="1100" dirty="0">
-                <a:solidFill>
-                  <a:schemeClr val="tx2"/>
-                </a:solidFill>
-              </a:rPr>
-              <a:t>kids · 4 à 11 ans</a:t>
-            </a:r>
-            <a:endParaRPr lang="en-US" sz="1100" dirty="0"/>
-          </a:p>
-        </p:txBody>
-      </p:sp>
-      <p:sp>
-        <p:nvSpPr>
-          <p:cNvPr id="8" name="Text 5"/>
-          <p:cNvSpPr txBox="1"/>
-          <p:nvPr/>
-        </p:nvSpPr>
-        <p:spPr>
-          <a:xfrm>
-            <a:off x="457200" y="4005072"/>
-            <a:ext cx="1920240" cy="274320"/>
-          </a:xfrm>
-          <a:prstGeom prst="rect">
-            <a:avLst/>
-          </a:prstGeom>
-          <a:noFill/>
-          <a:ln/>
-        </p:spPr>
-        <p:txBody>
-          <a:bodyPr wrap="square" lIns="0" tIns="0" rIns="0" bIns="0" rtlCol="0" anchor="ctr"/>
-          <a:lstStyle/>
-          <a:p>
-            <a:pPr indent="0" marL="0">
-              <a:buNone/>
-            </a:pPr>
-            <a:r>
-              <a:rPr lang="en-US" sz="1100" b="1" dirty="0">
-                <a:solidFill>
-                  <a:schemeClr val="tx1"/>
-                </a:solidFill>
-              </a:rPr>
-              <a:t>boost · grow · focus · dodo</a:t>
-            </a:r>
-            <a:endParaRPr lang="en-US" sz="1100" dirty="0"/>
-          </a:p>
-        </p:txBody>
-      </p:sp>
       <p:pic>
         <p:nvPicPr>
-          <p:cNvPr id="9" name="lineup-active" descr="Étuis straw. active">    </p:cNvPr>
+          <p:cNvPr id="5" name="packs-mini" descr="Étuis straw. mini">    </p:cNvPr>
           <p:cNvPicPr>
             <a:picLocks noChangeAspect="1"/>
           </p:cNvPicPr>
@@ -7946,8 +7804,8 @@
         </p:blipFill>
         <p:spPr>
           <a:xfrm>
-            <a:off x="2560320" y="1280160"/>
-            <a:ext cx="1920240" cy="2011680"/>
+            <a:off x="548640" y="2409338"/>
+            <a:ext cx="1051560" cy="562462"/>
           </a:xfrm>
           <a:prstGeom prst="rect">
             <a:avLst/>
@@ -7956,33 +7814,33 @@
       </p:pic>
       <p:sp>
         <p:nvSpPr>
-          <p:cNvPr id="10" name="Shape 6"/>
+          <p:cNvPr id="6" name="Shape 2"/>
           <p:cNvSpPr/>
           <p:nvPr/>
         </p:nvSpPr>
         <p:spPr>
           <a:xfrm>
-            <a:off x="2560320" y="3474720"/>
+            <a:off x="457200" y="3291840"/>
             <a:ext cx="146304" cy="146304"/>
           </a:xfrm>
           <a:prstGeom prst="ellipse">
             <a:avLst/>
           </a:prstGeom>
           <a:solidFill>
-            <a:schemeClr val="accent4"/>
+            <a:schemeClr val="accent3"/>
           </a:solidFill>
           <a:ln/>
         </p:spPr>
       </p:sp>
       <p:sp>
         <p:nvSpPr>
-          <p:cNvPr id="11" name="Text 7"/>
+          <p:cNvPr id="7" name="Text 3"/>
           <p:cNvSpPr txBox="1"/>
           <p:nvPr/>
         </p:nvSpPr>
         <p:spPr>
           <a:xfrm>
-            <a:off x="2779776" y="3383280"/>
+            <a:off x="676656" y="3200400"/>
             <a:ext cx="1737360" cy="320040"/>
           </a:xfrm>
           <a:prstGeom prst="rect">
@@ -8018,7 +7876,7 @@
                 <a:ea typeface="Cambria" pitchFamily="34" charset="-122"/>
                 <a:cs typeface="Cambria" pitchFamily="34" charset="-120"/>
               </a:rPr>
-              <a:t>active</a:t>
+              <a:t>mini</a:t>
             </a:r>
             <a:endParaRPr lang="en-US" sz="1700" dirty="0"/>
           </a:p>
@@ -8026,13 +7884,13 @@
       </p:sp>
       <p:sp>
         <p:nvSpPr>
-          <p:cNvPr id="12" name="Text 8"/>
+          <p:cNvPr id="8" name="Text 4"/>
           <p:cNvSpPr txBox="1"/>
           <p:nvPr/>
         </p:nvSpPr>
         <p:spPr>
           <a:xfrm>
-            <a:off x="2560320" y="3730752"/>
+            <a:off x="457200" y="3566160"/>
             <a:ext cx="1920240" cy="274320"/>
           </a:xfrm>
           <a:prstGeom prst="rect">
@@ -8054,7 +7912,7 @@
                   <a:schemeClr val="tx2"/>
                 </a:solidFill>
               </a:rPr>
-              <a:t>femme active · 20 à 45 ans</a:t>
+              <a:t>kids · 4 à 11 ans</a:t>
             </a:r>
             <a:endParaRPr lang="en-US" sz="1100" dirty="0"/>
           </a:p>
@@ -8062,13 +7920,13 @@
       </p:sp>
       <p:sp>
         <p:nvSpPr>
-          <p:cNvPr id="13" name="Text 9"/>
+          <p:cNvPr id="9" name="Text 5"/>
           <p:cNvSpPr txBox="1"/>
           <p:nvPr/>
         </p:nvSpPr>
         <p:spPr>
           <a:xfrm>
-            <a:off x="2560320" y="4005072"/>
+            <a:off x="457200" y="4041648"/>
             <a:ext cx="1920240" cy="274320"/>
           </a:xfrm>
           <a:prstGeom prst="rect">
@@ -8090,7 +7948,7 @@
                   <a:schemeClr val="tx1"/>
                 </a:solidFill>
               </a:rPr>
-              <a:t>rise · pulse · move · sleep</a:t>
+              <a:t>boost · grow · focus · dodo</a:t>
             </a:r>
             <a:endParaRPr lang="en-US" sz="1100" dirty="0"/>
           </a:p>
@@ -8098,7 +7956,7 @@
       </p:sp>
       <p:pic>
         <p:nvPicPr>
-          <p:cNvPr id="14" name="lineup-luna" descr="Étuis straw. luna">    </p:cNvPr>
+          <p:cNvPr id="10" name="mood-active" descr="mood-active">    </p:cNvPr>
           <p:cNvPicPr>
             <a:picLocks noChangeAspect="1"/>
           </p:cNvPicPr>
@@ -8112,159 +7970,17 @@
         </p:blipFill>
         <p:spPr>
           <a:xfrm>
-            <a:off x="4663440" y="1280160"/>
-            <a:ext cx="1920240" cy="2011680"/>
+            <a:off x="2560320" y="1234440"/>
+            <a:ext cx="1920240" cy="1828800"/>
           </a:xfrm>
           <a:prstGeom prst="rect">
             <a:avLst/>
           </a:prstGeom>
         </p:spPr>
       </p:pic>
-      <p:sp>
-        <p:nvSpPr>
-          <p:cNvPr id="15" name="Shape 10"/>
-          <p:cNvSpPr/>
-          <p:nvPr/>
-        </p:nvSpPr>
-        <p:spPr>
-          <a:xfrm>
-            <a:off x="4663440" y="3474720"/>
-            <a:ext cx="146304" cy="146304"/>
-          </a:xfrm>
-          <a:prstGeom prst="ellipse">
-            <a:avLst/>
-          </a:prstGeom>
-          <a:solidFill>
-            <a:schemeClr val="accent1"/>
-          </a:solidFill>
-          <a:ln/>
-        </p:spPr>
-      </p:sp>
-      <p:sp>
-        <p:nvSpPr>
-          <p:cNvPr id="16" name="Text 11"/>
-          <p:cNvSpPr txBox="1"/>
-          <p:nvPr/>
-        </p:nvSpPr>
-        <p:spPr>
-          <a:xfrm>
-            <a:off x="4882896" y="3383280"/>
-            <a:ext cx="1737360" cy="320040"/>
-          </a:xfrm>
-          <a:prstGeom prst="rect">
-            <a:avLst/>
-          </a:prstGeom>
-          <a:noFill/>
-          <a:ln/>
-        </p:spPr>
-        <p:txBody>
-          <a:bodyPr wrap="square" lIns="0" tIns="0" rIns="0" bIns="0" rtlCol="0" anchor="ctr"/>
-          <a:lstStyle/>
-          <a:p>
-            <a:pPr indent="0" marL="0">
-              <a:buNone/>
-            </a:pPr>
-            <a:r>
-              <a:rPr lang="en-US" sz="1700" b="1" dirty="0">
-                <a:solidFill>
-                  <a:schemeClr val="tx1"/>
-                </a:solidFill>
-              </a:rPr>
-              <a:t>straw. </a:t>
-            </a:r>
-            <a:pPr indent="0" marL="0">
-              <a:buNone/>
-            </a:pPr>
-            <a:r>
-              <a:rPr lang="en-US" sz="1700" i="1" dirty="0">
-                <a:solidFill>
-                  <a:schemeClr val="tx1"/>
-                </a:solidFill>
-                <a:latin typeface="Cambria" pitchFamily="34" charset="0"/>
-                <a:ea typeface="Cambria" pitchFamily="34" charset="-122"/>
-                <a:cs typeface="Cambria" pitchFamily="34" charset="-120"/>
-              </a:rPr>
-              <a:t>luna</a:t>
-            </a:r>
-            <a:endParaRPr lang="en-US" sz="1700" dirty="0"/>
-          </a:p>
-        </p:txBody>
-      </p:sp>
-      <p:sp>
-        <p:nvSpPr>
-          <p:cNvPr id="17" name="Text 12"/>
-          <p:cNvSpPr txBox="1"/>
-          <p:nvPr/>
-        </p:nvSpPr>
-        <p:spPr>
-          <a:xfrm>
-            <a:off x="4663440" y="3730752"/>
-            <a:ext cx="1920240" cy="274320"/>
-          </a:xfrm>
-          <a:prstGeom prst="rect">
-            <a:avLst/>
-          </a:prstGeom>
-          <a:noFill/>
-          <a:ln/>
-        </p:spPr>
-        <p:txBody>
-          <a:bodyPr wrap="square" lIns="0" tIns="0" rIns="0" bIns="0" rtlCol="0" anchor="ctr"/>
-          <a:lstStyle/>
-          <a:p>
-            <a:pPr indent="0" marL="0">
-              <a:buNone/>
-            </a:pPr>
-            <a:r>
-              <a:rPr lang="en-US" sz="1100" dirty="0">
-                <a:solidFill>
-                  <a:schemeClr val="tx2"/>
-                </a:solidFill>
-              </a:rPr>
-              <a:t>santé féminine · cycle → ménopause</a:t>
-            </a:r>
-            <a:endParaRPr lang="en-US" sz="1100" dirty="0"/>
-          </a:p>
-        </p:txBody>
-      </p:sp>
-      <p:sp>
-        <p:nvSpPr>
-          <p:cNvPr id="18" name="Text 13"/>
-          <p:cNvSpPr txBox="1"/>
-          <p:nvPr/>
-        </p:nvSpPr>
-        <p:spPr>
-          <a:xfrm>
-            <a:off x="4663440" y="4005072"/>
-            <a:ext cx="1920240" cy="274320"/>
-          </a:xfrm>
-          <a:prstGeom prst="rect">
-            <a:avLst/>
-          </a:prstGeom>
-          <a:noFill/>
-          <a:ln/>
-        </p:spPr>
-        <p:txBody>
-          <a:bodyPr wrap="square" lIns="0" tIns="0" rIns="0" bIns="0" rtlCol="0" anchor="ctr"/>
-          <a:lstStyle/>
-          <a:p>
-            <a:pPr indent="0" marL="0">
-              <a:buNone/>
-            </a:pPr>
-            <a:r>
-              <a:rPr lang="en-US" sz="1100" b="1" dirty="0">
-                <a:solidFill>
-                  <a:schemeClr val="tx1"/>
-                </a:solidFill>
-              </a:rPr>
-              <a:t>flow · balance · bloom · meno</a:t>
-            </a:r>
-            <a:endParaRPr lang="en-US" sz="1100" dirty="0"/>
-          </a:p>
-        </p:txBody>
-      </p:sp>
       <p:pic>
         <p:nvPicPr>
-          <p:cNvPr id="19" name="lineup-silver" descr="Étuis straw. silver">    </p:cNvPr>
+          <p:cNvPr id="11" name="packs-active" descr="Étuis straw. active">    </p:cNvPr>
           <p:cNvPicPr>
             <a:picLocks noChangeAspect="1"/>
           </p:cNvPicPr>
@@ -8278,8 +7994,8 @@
         </p:blipFill>
         <p:spPr>
           <a:xfrm>
-            <a:off x="6766560" y="1280160"/>
-            <a:ext cx="1920240" cy="2011680"/>
+            <a:off x="2651760" y="2433793"/>
+            <a:ext cx="1051560" cy="538007"/>
           </a:xfrm>
           <a:prstGeom prst="rect">
             <a:avLst/>
@@ -8288,13 +8004,393 @@
       </p:pic>
       <p:sp>
         <p:nvSpPr>
-          <p:cNvPr id="20" name="Shape 14"/>
+          <p:cNvPr id="12" name="Shape 6"/>
           <p:cNvSpPr/>
           <p:nvPr/>
         </p:nvSpPr>
         <p:spPr>
           <a:xfrm>
-            <a:off x="6766560" y="3474720"/>
+            <a:off x="2560320" y="3291840"/>
+            <a:ext cx="146304" cy="146304"/>
+          </a:xfrm>
+          <a:prstGeom prst="ellipse">
+            <a:avLst/>
+          </a:prstGeom>
+          <a:solidFill>
+            <a:schemeClr val="accent4"/>
+          </a:solidFill>
+          <a:ln/>
+        </p:spPr>
+      </p:sp>
+      <p:sp>
+        <p:nvSpPr>
+          <p:cNvPr id="13" name="Text 7"/>
+          <p:cNvSpPr txBox="1"/>
+          <p:nvPr/>
+        </p:nvSpPr>
+        <p:spPr>
+          <a:xfrm>
+            <a:off x="2779776" y="3200400"/>
+            <a:ext cx="1737360" cy="320040"/>
+          </a:xfrm>
+          <a:prstGeom prst="rect">
+            <a:avLst/>
+          </a:prstGeom>
+          <a:noFill/>
+          <a:ln/>
+        </p:spPr>
+        <p:txBody>
+          <a:bodyPr wrap="square" lIns="0" tIns="0" rIns="0" bIns="0" rtlCol="0" anchor="ctr"/>
+          <a:lstStyle/>
+          <a:p>
+            <a:pPr indent="0" marL="0">
+              <a:buNone/>
+            </a:pPr>
+            <a:r>
+              <a:rPr lang="en-US" sz="1700" b="1" dirty="0">
+                <a:solidFill>
+                  <a:schemeClr val="tx1"/>
+                </a:solidFill>
+              </a:rPr>
+              <a:t>straw. </a:t>
+            </a:r>
+            <a:pPr indent="0" marL="0">
+              <a:buNone/>
+            </a:pPr>
+            <a:r>
+              <a:rPr lang="en-US" sz="1700" i="1" dirty="0">
+                <a:solidFill>
+                  <a:schemeClr val="tx1"/>
+                </a:solidFill>
+                <a:latin typeface="Cambria" pitchFamily="34" charset="0"/>
+                <a:ea typeface="Cambria" pitchFamily="34" charset="-122"/>
+                <a:cs typeface="Cambria" pitchFamily="34" charset="-120"/>
+              </a:rPr>
+              <a:t>active</a:t>
+            </a:r>
+            <a:endParaRPr lang="en-US" sz="1700" dirty="0"/>
+          </a:p>
+        </p:txBody>
+      </p:sp>
+      <p:sp>
+        <p:nvSpPr>
+          <p:cNvPr id="14" name="Text 8"/>
+          <p:cNvSpPr txBox="1"/>
+          <p:nvPr/>
+        </p:nvSpPr>
+        <p:spPr>
+          <a:xfrm>
+            <a:off x="2560320" y="3566160"/>
+            <a:ext cx="1920240" cy="274320"/>
+          </a:xfrm>
+          <a:prstGeom prst="rect">
+            <a:avLst/>
+          </a:prstGeom>
+          <a:noFill/>
+          <a:ln/>
+        </p:spPr>
+        <p:txBody>
+          <a:bodyPr wrap="square" lIns="0" tIns="0" rIns="0" bIns="0" rtlCol="0" anchor="ctr"/>
+          <a:lstStyle/>
+          <a:p>
+            <a:pPr indent="0" marL="0">
+              <a:buNone/>
+            </a:pPr>
+            <a:r>
+              <a:rPr lang="en-US" sz="1100" dirty="0">
+                <a:solidFill>
+                  <a:schemeClr val="tx2"/>
+                </a:solidFill>
+              </a:rPr>
+              <a:t>femme active · 20 à 45 ans</a:t>
+            </a:r>
+            <a:endParaRPr lang="en-US" sz="1100" dirty="0"/>
+          </a:p>
+        </p:txBody>
+      </p:sp>
+      <p:sp>
+        <p:nvSpPr>
+          <p:cNvPr id="15" name="Text 9"/>
+          <p:cNvSpPr txBox="1"/>
+          <p:nvPr/>
+        </p:nvSpPr>
+        <p:spPr>
+          <a:xfrm>
+            <a:off x="2560320" y="4041648"/>
+            <a:ext cx="1920240" cy="274320"/>
+          </a:xfrm>
+          <a:prstGeom prst="rect">
+            <a:avLst/>
+          </a:prstGeom>
+          <a:noFill/>
+          <a:ln/>
+        </p:spPr>
+        <p:txBody>
+          <a:bodyPr wrap="square" lIns="0" tIns="0" rIns="0" bIns="0" rtlCol="0" anchor="ctr"/>
+          <a:lstStyle/>
+          <a:p>
+            <a:pPr indent="0" marL="0">
+              <a:buNone/>
+            </a:pPr>
+            <a:r>
+              <a:rPr lang="en-US" sz="1100" b="1" dirty="0">
+                <a:solidFill>
+                  <a:schemeClr val="tx1"/>
+                </a:solidFill>
+              </a:rPr>
+              <a:t>rise · pulse · move · sleep</a:t>
+            </a:r>
+            <a:endParaRPr lang="en-US" sz="1100" dirty="0"/>
+          </a:p>
+        </p:txBody>
+      </p:sp>
+      <p:pic>
+        <p:nvPicPr>
+          <p:cNvPr id="16" name="mood-luna" descr="mood-luna">    </p:cNvPr>
+          <p:cNvPicPr>
+            <a:picLocks noChangeAspect="1"/>
+          </p:cNvPicPr>
+          <p:nvPr/>
+        </p:nvPicPr>
+        <p:blipFill>
+          <a:blip r:embed="rId5"/>
+          <a:stretch>
+            <a:fillRect/>
+          </a:stretch>
+        </p:blipFill>
+        <p:spPr>
+          <a:xfrm>
+            <a:off x="4663440" y="1234440"/>
+            <a:ext cx="1920240" cy="1828800"/>
+          </a:xfrm>
+          <a:prstGeom prst="rect">
+            <a:avLst/>
+          </a:prstGeom>
+        </p:spPr>
+      </p:pic>
+      <p:pic>
+        <p:nvPicPr>
+          <p:cNvPr id="17" name="packs-luna" descr="Étuis straw. luna">    </p:cNvPr>
+          <p:cNvPicPr>
+            <a:picLocks noChangeAspect="1"/>
+          </p:cNvPicPr>
+          <p:nvPr/>
+        </p:nvPicPr>
+        <p:blipFill>
+          <a:blip r:embed="rId6"/>
+          <a:stretch>
+            <a:fillRect/>
+          </a:stretch>
+        </p:blipFill>
+        <p:spPr>
+          <a:xfrm>
+            <a:off x="4754880" y="2409338"/>
+            <a:ext cx="1051560" cy="562462"/>
+          </a:xfrm>
+          <a:prstGeom prst="rect">
+            <a:avLst/>
+          </a:prstGeom>
+        </p:spPr>
+      </p:pic>
+      <p:sp>
+        <p:nvSpPr>
+          <p:cNvPr id="18" name="Shape 10"/>
+          <p:cNvSpPr/>
+          <p:nvPr/>
+        </p:nvSpPr>
+        <p:spPr>
+          <a:xfrm>
+            <a:off x="4663440" y="3291840"/>
+            <a:ext cx="146304" cy="146304"/>
+          </a:xfrm>
+          <a:prstGeom prst="ellipse">
+            <a:avLst/>
+          </a:prstGeom>
+          <a:solidFill>
+            <a:schemeClr val="accent1"/>
+          </a:solidFill>
+          <a:ln/>
+        </p:spPr>
+      </p:sp>
+      <p:sp>
+        <p:nvSpPr>
+          <p:cNvPr id="19" name="Text 11"/>
+          <p:cNvSpPr txBox="1"/>
+          <p:nvPr/>
+        </p:nvSpPr>
+        <p:spPr>
+          <a:xfrm>
+            <a:off x="4882896" y="3200400"/>
+            <a:ext cx="1737360" cy="320040"/>
+          </a:xfrm>
+          <a:prstGeom prst="rect">
+            <a:avLst/>
+          </a:prstGeom>
+          <a:noFill/>
+          <a:ln/>
+        </p:spPr>
+        <p:txBody>
+          <a:bodyPr wrap="square" lIns="0" tIns="0" rIns="0" bIns="0" rtlCol="0" anchor="ctr"/>
+          <a:lstStyle/>
+          <a:p>
+            <a:pPr indent="0" marL="0">
+              <a:buNone/>
+            </a:pPr>
+            <a:r>
+              <a:rPr lang="en-US" sz="1700" b="1" dirty="0">
+                <a:solidFill>
+                  <a:schemeClr val="tx1"/>
+                </a:solidFill>
+              </a:rPr>
+              <a:t>straw. </a:t>
+            </a:r>
+            <a:pPr indent="0" marL="0">
+              <a:buNone/>
+            </a:pPr>
+            <a:r>
+              <a:rPr lang="en-US" sz="1700" i="1" dirty="0">
+                <a:solidFill>
+                  <a:schemeClr val="tx1"/>
+                </a:solidFill>
+                <a:latin typeface="Cambria" pitchFamily="34" charset="0"/>
+                <a:ea typeface="Cambria" pitchFamily="34" charset="-122"/>
+                <a:cs typeface="Cambria" pitchFamily="34" charset="-120"/>
+              </a:rPr>
+              <a:t>luna</a:t>
+            </a:r>
+            <a:endParaRPr lang="en-US" sz="1700" dirty="0"/>
+          </a:p>
+        </p:txBody>
+      </p:sp>
+      <p:sp>
+        <p:nvSpPr>
+          <p:cNvPr id="20" name="Text 12"/>
+          <p:cNvSpPr txBox="1"/>
+          <p:nvPr/>
+        </p:nvSpPr>
+        <p:spPr>
+          <a:xfrm>
+            <a:off x="4663440" y="3566160"/>
+            <a:ext cx="1920240" cy="274320"/>
+          </a:xfrm>
+          <a:prstGeom prst="rect">
+            <a:avLst/>
+          </a:prstGeom>
+          <a:noFill/>
+          <a:ln/>
+        </p:spPr>
+        <p:txBody>
+          <a:bodyPr wrap="square" lIns="0" tIns="0" rIns="0" bIns="0" rtlCol="0" anchor="ctr"/>
+          <a:lstStyle/>
+          <a:p>
+            <a:pPr indent="0" marL="0">
+              <a:buNone/>
+            </a:pPr>
+            <a:r>
+              <a:rPr lang="en-US" sz="1100" dirty="0">
+                <a:solidFill>
+                  <a:schemeClr val="tx2"/>
+                </a:solidFill>
+              </a:rPr>
+              <a:t>santé féminine · cycle → ménopause</a:t>
+            </a:r>
+            <a:endParaRPr lang="en-US" sz="1100" dirty="0"/>
+          </a:p>
+        </p:txBody>
+      </p:sp>
+      <p:sp>
+        <p:nvSpPr>
+          <p:cNvPr id="21" name="Text 13"/>
+          <p:cNvSpPr txBox="1"/>
+          <p:nvPr/>
+        </p:nvSpPr>
+        <p:spPr>
+          <a:xfrm>
+            <a:off x="4663440" y="4041648"/>
+            <a:ext cx="1920240" cy="274320"/>
+          </a:xfrm>
+          <a:prstGeom prst="rect">
+            <a:avLst/>
+          </a:prstGeom>
+          <a:noFill/>
+          <a:ln/>
+        </p:spPr>
+        <p:txBody>
+          <a:bodyPr wrap="square" lIns="0" tIns="0" rIns="0" bIns="0" rtlCol="0" anchor="ctr"/>
+          <a:lstStyle/>
+          <a:p>
+            <a:pPr indent="0" marL="0">
+              <a:buNone/>
+            </a:pPr>
+            <a:r>
+              <a:rPr lang="en-US" sz="1100" b="1" dirty="0">
+                <a:solidFill>
+                  <a:schemeClr val="tx1"/>
+                </a:solidFill>
+              </a:rPr>
+              <a:t>flow · balance · bloom · meno</a:t>
+            </a:r>
+            <a:endParaRPr lang="en-US" sz="1100" dirty="0"/>
+          </a:p>
+        </p:txBody>
+      </p:sp>
+      <p:pic>
+        <p:nvPicPr>
+          <p:cNvPr id="22" name="mood-silver" descr="mood-silver">    </p:cNvPr>
+          <p:cNvPicPr>
+            <a:picLocks noChangeAspect="1"/>
+          </p:cNvPicPr>
+          <p:nvPr/>
+        </p:nvPicPr>
+        <p:blipFill>
+          <a:blip r:embed="rId7"/>
+          <a:stretch>
+            <a:fillRect/>
+          </a:stretch>
+        </p:blipFill>
+        <p:spPr>
+          <a:xfrm>
+            <a:off x="6766560" y="1234440"/>
+            <a:ext cx="1920240" cy="1828800"/>
+          </a:xfrm>
+          <a:prstGeom prst="rect">
+            <a:avLst/>
+          </a:prstGeom>
+        </p:spPr>
+      </p:pic>
+      <p:pic>
+        <p:nvPicPr>
+          <p:cNvPr id="23" name="packs-silver" descr="Étuis straw. silver">    </p:cNvPr>
+          <p:cNvPicPr>
+            <a:picLocks noChangeAspect="1"/>
+          </p:cNvPicPr>
+          <p:nvPr/>
+        </p:nvPicPr>
+        <p:blipFill>
+          <a:blip r:embed="rId8"/>
+          <a:stretch>
+            <a:fillRect/>
+          </a:stretch>
+        </p:blipFill>
+        <p:spPr>
+          <a:xfrm>
+            <a:off x="6858000" y="2409338"/>
+            <a:ext cx="1051560" cy="562462"/>
+          </a:xfrm>
+          <a:prstGeom prst="rect">
+            <a:avLst/>
+          </a:prstGeom>
+        </p:spPr>
+      </p:pic>
+      <p:sp>
+        <p:nvSpPr>
+          <p:cNvPr id="24" name="Shape 14"/>
+          <p:cNvSpPr/>
+          <p:nvPr/>
+        </p:nvSpPr>
+        <p:spPr>
+          <a:xfrm>
+            <a:off x="6766560" y="3291840"/>
             <a:ext cx="146304" cy="146304"/>
           </a:xfrm>
           <a:prstGeom prst="ellipse">
@@ -8308,13 +8404,13 @@
       </p:sp>
       <p:sp>
         <p:nvSpPr>
-          <p:cNvPr id="21" name="Text 15"/>
+          <p:cNvPr id="25" name="Text 15"/>
           <p:cNvSpPr txBox="1"/>
           <p:nvPr/>
         </p:nvSpPr>
         <p:spPr>
           <a:xfrm>
-            <a:off x="6986016" y="3383280"/>
+            <a:off x="6986016" y="3200400"/>
             <a:ext cx="1737360" cy="320040"/>
           </a:xfrm>
           <a:prstGeom prst="rect">
@@ -8358,13 +8454,13 @@
       </p:sp>
       <p:sp>
         <p:nvSpPr>
-          <p:cNvPr id="22" name="Text 16"/>
+          <p:cNvPr id="26" name="Text 16"/>
           <p:cNvSpPr txBox="1"/>
           <p:nvPr/>
         </p:nvSpPr>
         <p:spPr>
           <a:xfrm>
-            <a:off x="6766560" y="3730752"/>
+            <a:off x="6766560" y="3566160"/>
             <a:ext cx="1920240" cy="274320"/>
           </a:xfrm>
           <a:prstGeom prst="rect">
@@ -8394,13 +8490,13 @@
       </p:sp>
       <p:sp>
         <p:nvSpPr>
-          <p:cNvPr id="23" name="Text 17"/>
+          <p:cNvPr id="27" name="Text 17"/>
           <p:cNvSpPr txBox="1"/>
           <p:nvPr/>
         </p:nvSpPr>
         <p:spPr>
           <a:xfrm>
-            <a:off x="6766560" y="4005072"/>
+            <a:off x="6766560" y="4041648"/>
             <a:ext cx="1920240" cy="274320"/>
           </a:xfrm>
           <a:prstGeom prst="rect">

</xml_diff>